<commit_message>
Mettre à jour les documents après unification des comptes
Co-authored-by: HB consulting and services  <hb.consulting.srv@gmail.com>
</commit_message>
<xml_diff>
--- a/docs/presentation-hb-commerce.pptx
+++ b/docs/presentation-hb-commerce.pptx
@@ -17,8 +17,6 @@
     <p:sldId id="265" r:id="rId16"/>
     <p:sldId id="266" r:id="rId17"/>
     <p:sldId id="267" r:id="rId18"/>
-    <p:sldId id="268" r:id="rId19"/>
-    <p:sldId id="269" r:id="rId20"/>
   </p:sldIdLst>
   <p:sldSz cx="12191695" cy="6858000" type="screen4x3"/>
   <p:notesSz cx="6858000" cy="9144000"/>
@@ -3154,7 +3152,7 @@
       </p:sp>
       <p:pic>
         <p:nvPicPr>
-          <p:cNvPr id="3" name="Picture 2" descr="hb-commerce-logo.png"/>
+          <p:cNvPr id="3" name="Picture 2" descr="hb-commerce-logo-temp.png"/>
           <p:cNvPicPr>
             <a:picLocks noChangeAspect="1"/>
           </p:cNvPicPr>
@@ -3184,8 +3182,8 @@
         </p:nvSpPr>
         <p:spPr>
           <a:xfrm>
-            <a:off x="9464040" y="155448"/>
-            <a:ext cx="2331720" cy="274320"/>
+            <a:off x="9326880" y="155448"/>
+            <a:ext cx="2560320" cy="274320"/>
           </a:xfrm>
           <a:prstGeom prst="rect">
             <a:avLst/>
@@ -3359,7 +3357,7 @@
                   <a:srgbClr val="2C2C2C"/>
                 </a:solidFill>
               </a:rPr>
-              <a:t>• Présentation fonctionnelle</a:t>
+              <a:t>• Présentation fonctionnelle consolidée</a:t>
             </a:r>
           </a:p>
         </p:txBody>
@@ -3437,7 +3435,7 @@
                   <a:srgbClr val="2C2C2C"/>
                 </a:solidFill>
               </a:rPr>
-              <a:t>• Commerce B2B huile d’olive FIAFI</a:t>
+              <a:t>• Mise à jour : 18/06/2026</a:t>
             </a:r>
           </a:p>
         </p:txBody>
@@ -3515,7 +3513,7 @@
                   <a:srgbClr val="2C2C2C"/>
                 </a:solidFill>
               </a:rPr>
-              <a:t>• Mise à jour : 18/06/2026</a:t>
+              <a:t>• Création unifiée sociétés et utilisateurs internes</a:t>
             </a:r>
           </a:p>
         </p:txBody>
@@ -3549,7 +3547,7 @@
                   <a:srgbClr val="666666"/>
                 </a:solidFill>
               </a:rPr>
-              <a:t>Présentation HB Commerce · 1/14</a:t>
+              <a:t>Présentation HB Commerce · 1/12</a:t>
             </a:r>
           </a:p>
         </p:txBody>
@@ -3625,7 +3623,7 @@
       </p:sp>
       <p:pic>
         <p:nvPicPr>
-          <p:cNvPr id="3" name="Picture 2" descr="hb-commerce-logo.png"/>
+          <p:cNvPr id="3" name="Picture 2" descr="hb-commerce-logo-temp.png"/>
           <p:cNvPicPr>
             <a:picLocks noChangeAspect="1"/>
           </p:cNvPicPr>
@@ -3655,8 +3653,8 @@
         </p:nvSpPr>
         <p:spPr>
           <a:xfrm>
-            <a:off x="9464040" y="155448"/>
-            <a:ext cx="2331720" cy="274320"/>
+            <a:off x="9326880" y="155448"/>
+            <a:ext cx="2560320" cy="274320"/>
           </a:xfrm>
           <a:prstGeom prst="rect">
             <a:avLst/>
@@ -3709,7 +3707,7 @@
                   <a:srgbClr val="0F3D32"/>
                 </a:solidFill>
               </a:rPr>
-              <a:t>Commandes, factures, livraison</a:t>
+              <a:t>Architecture</a:t>
             </a:r>
           </a:p>
         </p:txBody>
@@ -3830,7 +3828,7 @@
                   <a:srgbClr val="2C2C2C"/>
                 </a:solidFill>
               </a:rPr>
-              <a:t>• Statuts : validation, paiement, préparation, expédition, livraison, annulation</a:t>
+              <a:t>• GitHub Pages</a:t>
             </a:r>
           </a:p>
         </p:txBody>
@@ -3908,7 +3906,7 @@
                   <a:srgbClr val="2C2C2C"/>
                 </a:solidFill>
               </a:rPr>
-              <a:t>• Facture téléchargeable par commande</a:t>
+              <a:t>• Supabase Auth</a:t>
             </a:r>
           </a:p>
         </p:txBody>
@@ -3986,7 +3984,7 @@
                   <a:srgbClr val="2C2C2C"/>
                 </a:solidFill>
               </a:rPr>
-              <a:t>• Transporteur, numéro et lien de suivi</a:t>
+              <a:t>• Supabase Database + RLS</a:t>
             </a:r>
           </a:p>
         </p:txBody>
@@ -4064,7 +4062,7 @@
                   <a:srgbClr val="2C2C2C"/>
                 </a:solidFill>
               </a:rPr>
-              <a:t>• Date estimée et date livrée</a:t>
+              <a:t>• Migrations SQL versionnées</a:t>
             </a:r>
           </a:p>
         </p:txBody>
@@ -4142,7 +4140,7 @@
                   <a:srgbClr val="2C2C2C"/>
                 </a:solidFill>
               </a:rPr>
-              <a:t>• Notes de livraison conservées</a:t>
+              <a:t>• Dashboards HTML/JS</a:t>
             </a:r>
           </a:p>
         </p:txBody>
@@ -4176,7 +4174,7 @@
                   <a:srgbClr val="666666"/>
                 </a:solidFill>
               </a:rPr>
-              <a:t>Présentation HB Commerce · 10/14</a:t>
+              <a:t>Présentation HB Commerce · 10/12</a:t>
             </a:r>
           </a:p>
         </p:txBody>
@@ -4252,7 +4250,7 @@
       </p:sp>
       <p:pic>
         <p:nvPicPr>
-          <p:cNvPr id="3" name="Picture 2" descr="hb-commerce-logo.png"/>
+          <p:cNvPr id="3" name="Picture 2" descr="hb-commerce-logo-temp.png"/>
           <p:cNvPicPr>
             <a:picLocks noChangeAspect="1"/>
           </p:cNvPicPr>
@@ -4282,8 +4280,8 @@
         </p:nvSpPr>
         <p:spPr>
           <a:xfrm>
-            <a:off x="9464040" y="155448"/>
-            <a:ext cx="2331720" cy="274320"/>
+            <a:off x="9326880" y="155448"/>
+            <a:ext cx="2560320" cy="274320"/>
           </a:xfrm>
           <a:prstGeom prst="rect">
             <a:avLst/>
@@ -4336,7 +4334,7 @@
                   <a:srgbClr val="0F3D32"/>
                 </a:solidFill>
               </a:rPr>
-              <a:t>Chat &amp; modération</a:t>
+              <a:t>Migrations SQL</a:t>
             </a:r>
           </a:p>
         </p:txBody>
@@ -4457,7 +4455,7 @@
                   <a:srgbClr val="2C2C2C"/>
                 </a:solidFill>
               </a:rPr>
-              <a:t>• Historique conservé</a:t>
+              <a:t>• migration-access-chat-pricing.sql</a:t>
             </a:r>
           </a:p>
         </p:txBody>
@@ -4535,7 +4533,7 @@
                   <a:srgbClr val="2C2C2C"/>
                 </a:solidFill>
               </a:rPr>
-              <a:t>• Messages client en attente de validation</a:t>
+              <a:t>• migration-company-client-fields.sql</a:t>
             </a:r>
           </a:p>
         </p:txBody>
@@ -4613,7 +4611,7 @@
                   <a:srgbClr val="2C2C2C"/>
                 </a:solidFill>
               </a:rPr>
-              <a:t>• Admin/agent peut accepter ou refuser</a:t>
+              <a:t>• migration-commercial-agents.sql</a:t>
             </a:r>
           </a:p>
         </p:txBody>
@@ -4691,7 +4689,7 @@
                   <a:srgbClr val="2C2C2C"/>
                 </a:solidFill>
               </a:rPr>
-              <a:t>• Commentaires refusés non visibles dans le fil validé</a:t>
+              <a:t>• migration-order-delivery-tracking.sql</a:t>
             </a:r>
           </a:p>
         </p:txBody>
@@ -4769,7 +4767,7 @@
                   <a:srgbClr val="2C2C2C"/>
                 </a:solidFill>
               </a:rPr>
-              <a:t>• Échanges dédiés à la finalisation des commandes</a:t>
+              <a:t>• migration-suppliers.sql</a:t>
             </a:r>
           </a:p>
         </p:txBody>
@@ -4803,7 +4801,7 @@
                   <a:srgbClr val="666666"/>
                 </a:solidFill>
               </a:rPr>
-              <a:t>Présentation HB Commerce · 11/14</a:t>
+              <a:t>Présentation HB Commerce · 11/12</a:t>
             </a:r>
           </a:p>
         </p:txBody>
@@ -4879,7 +4877,7 @@
       </p:sp>
       <p:pic>
         <p:nvPicPr>
-          <p:cNvPr id="3" name="Picture 2" descr="hb-commerce-logo.png"/>
+          <p:cNvPr id="3" name="Picture 2" descr="hb-commerce-logo-temp.png"/>
           <p:cNvPicPr>
             <a:picLocks noChangeAspect="1"/>
           </p:cNvPicPr>
@@ -4909,8 +4907,8 @@
         </p:nvSpPr>
         <p:spPr>
           <a:xfrm>
-            <a:off x="9464040" y="155448"/>
-            <a:ext cx="2331720" cy="274320"/>
+            <a:off x="9326880" y="155448"/>
+            <a:ext cx="2560320" cy="274320"/>
           </a:xfrm>
           <a:prstGeom prst="rect">
             <a:avLst/>
@@ -4963,7 +4961,7 @@
                   <a:srgbClr val="0F3D32"/>
                 </a:solidFill>
               </a:rPr>
-              <a:t>Architecture technique</a:t>
+              <a:t>Critères clés</a:t>
             </a:r>
           </a:p>
         </p:txBody>
@@ -5084,7 +5082,7 @@
                   <a:srgbClr val="2C2C2C"/>
                 </a:solidFill>
               </a:rPr>
-              <a:t>• Frontend statique HTML/CSS/JS sur GitHub Pages</a:t>
+              <a:t>• Admin ne crée pas de super root</a:t>
             </a:r>
           </a:p>
         </p:txBody>
@@ -5162,7 +5160,7 @@
                   <a:srgbClr val="2C2C2C"/>
                 </a:solidFill>
               </a:rPr>
-              <a:t>• Supabase Auth pour les comptes</a:t>
+              <a:t>• Fournisseur voit son stock</a:t>
             </a:r>
           </a:p>
         </p:txBody>
@@ -5240,7 +5238,7 @@
                   <a:srgbClr val="2C2C2C"/>
                 </a:solidFill>
               </a:rPr>
-              <a:t>• Supabase Database pour données métier</a:t>
+              <a:t>• Agent voit ses clients</a:t>
             </a:r>
           </a:p>
         </p:txBody>
@@ -5318,7 +5316,7 @@
                   <a:srgbClr val="2C2C2C"/>
                 </a:solidFill>
               </a:rPr>
-              <a:t>• RLS pour isoler client, agent, fournisseur</a:t>
+              <a:t>• Client voit ses factures</a:t>
             </a:r>
           </a:p>
         </p:txBody>
@@ -5396,7 +5394,7 @@
                   <a:srgbClr val="2C2C2C"/>
                 </a:solidFill>
               </a:rPr>
-              <a:t>• Migrations SQL versionnées dans le repo</a:t>
+              <a:t>• Société inscrite attend affectation</a:t>
             </a:r>
           </a:p>
         </p:txBody>
@@ -5430,1261 +5428,7 @@
                   <a:srgbClr val="666666"/>
                 </a:solidFill>
               </a:rPr>
-              <a:t>Présentation HB Commerce · 12/14</a:t>
-            </a:r>
-          </a:p>
-        </p:txBody>
-      </p:sp>
-    </p:spTree>
-  </p:cSld>
-  <p:clrMapOvr>
-    <a:masterClrMapping/>
-  </p:clrMapOvr>
-</p:sld>
-</file>
-
-<file path=ppt/slides/slide13.xml><?xml version="1.0" encoding="utf-8"?>
-<p:sld xmlns:a="http://schemas.openxmlformats.org/drawingml/2006/main" xmlns:p="http://schemas.openxmlformats.org/presentationml/2006/main" xmlns:r="http://schemas.openxmlformats.org/officeDocument/2006/relationships">
-  <p:cSld>
-    <p:bg>
-      <p:bgPr>
-        <a:solidFill>
-          <a:srgbClr val="FAF8F4"/>
-        </a:solidFill>
-        <a:effectLst/>
-      </p:bgPr>
-    </p:bg>
-    <p:spTree>
-      <p:nvGrpSpPr>
-        <p:cNvPr id="1" name=""/>
-        <p:cNvGrpSpPr/>
-        <p:nvPr/>
-      </p:nvGrpSpPr>
-      <p:grpSpPr/>
-      <p:sp>
-        <p:nvSpPr>
-          <p:cNvPr id="2" name="Rectangle 1"/>
-          <p:cNvSpPr/>
-          <p:nvPr/>
-        </p:nvSpPr>
-        <p:spPr>
-          <a:xfrm>
-            <a:off x="0" y="0"/>
-            <a:ext cx="12191695" cy="566928"/>
-          </a:xfrm>
-          <a:prstGeom prst="rect">
-            <a:avLst/>
-          </a:prstGeom>
-          <a:solidFill>
-            <a:srgbClr val="0F3D32"/>
-          </a:solidFill>
-          <a:ln>
-            <a:noFill/>
-          </a:ln>
-        </p:spPr>
-        <p:style>
-          <a:lnRef idx="1">
-            <a:schemeClr val="accent1"/>
-          </a:lnRef>
-          <a:fillRef idx="3">
-            <a:schemeClr val="accent1"/>
-          </a:fillRef>
-          <a:effectRef idx="2">
-            <a:schemeClr val="accent1"/>
-          </a:effectRef>
-          <a:fontRef idx="minor">
-            <a:schemeClr val="lt1"/>
-          </a:fontRef>
-        </p:style>
-        <p:txBody>
-          <a:bodyPr rtlCol="0" anchor="ctr"/>
-          <a:lstStyle/>
-          <a:p>
-            <a:pPr algn="ctr"/>
-          </a:p>
-        </p:txBody>
-      </p:sp>
-      <p:pic>
-        <p:nvPicPr>
-          <p:cNvPr id="3" name="Picture 2" descr="hb-commerce-logo.png"/>
-          <p:cNvPicPr>
-            <a:picLocks noChangeAspect="1"/>
-          </p:cNvPicPr>
-          <p:nvPr/>
-        </p:nvPicPr>
-        <p:blipFill>
-          <a:blip r:embed="rId2"/>
-          <a:stretch>
-            <a:fillRect/>
-          </a:stretch>
-        </p:blipFill>
-        <p:spPr>
-          <a:xfrm>
-            <a:off x="320040" y="100584"/>
-            <a:ext cx="2148840" cy="429768"/>
-          </a:xfrm>
-          <a:prstGeom prst="rect">
-            <a:avLst/>
-          </a:prstGeom>
-        </p:spPr>
-      </p:pic>
-      <p:sp>
-        <p:nvSpPr>
-          <p:cNvPr id="4" name="TextBox 3"/>
-          <p:cNvSpPr txBox="1"/>
-          <p:nvPr/>
-        </p:nvSpPr>
-        <p:spPr>
-          <a:xfrm>
-            <a:off x="9464040" y="155448"/>
-            <a:ext cx="2331720" cy="274320"/>
-          </a:xfrm>
-          <a:prstGeom prst="rect">
-            <a:avLst/>
-          </a:prstGeom>
-          <a:noFill/>
-        </p:spPr>
-        <p:txBody>
-          <a:bodyPr wrap="none">
-            <a:spAutoFit/>
-          </a:bodyPr>
-          <a:lstStyle/>
-          <a:p>
-            <a:pPr algn="r"/>
-            <a:r>
-              <a:rPr sz="1200" b="1">
-                <a:solidFill>
-                  <a:srgbClr val="FFFFFF"/>
-                </a:solidFill>
-              </a:rPr>
-              <a:t>HB Commerce</a:t>
-            </a:r>
-          </a:p>
-        </p:txBody>
-      </p:sp>
-      <p:sp>
-        <p:nvSpPr>
-          <p:cNvPr id="5" name="TextBox 4"/>
-          <p:cNvSpPr txBox="1"/>
-          <p:nvPr/>
-        </p:nvSpPr>
-        <p:spPr>
-          <a:xfrm>
-            <a:off x="594360" y="868680"/>
-            <a:ext cx="10789920" cy="640080"/>
-          </a:xfrm>
-          <a:prstGeom prst="rect">
-            <a:avLst/>
-          </a:prstGeom>
-          <a:noFill/>
-        </p:spPr>
-        <p:txBody>
-          <a:bodyPr wrap="none">
-            <a:spAutoFit/>
-          </a:bodyPr>
-          <a:lstStyle/>
-          <a:p>
-            <a:r>
-              <a:rPr sz="3200" b="1">
-                <a:solidFill>
-                  <a:srgbClr val="0F3D32"/>
-                </a:solidFill>
-              </a:rPr>
-              <a:t>Migrations Supabase clés</a:t>
-            </a:r>
-          </a:p>
-        </p:txBody>
-      </p:sp>
-      <p:sp>
-        <p:nvSpPr>
-          <p:cNvPr id="6" name="Rectangle 5"/>
-          <p:cNvSpPr/>
-          <p:nvPr/>
-        </p:nvSpPr>
-        <p:spPr>
-          <a:xfrm>
-            <a:off x="594360" y="1536192"/>
-            <a:ext cx="1874519" cy="54864"/>
-          </a:xfrm>
-          <a:prstGeom prst="rect">
-            <a:avLst/>
-          </a:prstGeom>
-          <a:solidFill>
-            <a:srgbClr val="C9A227"/>
-          </a:solidFill>
-          <a:ln>
-            <a:noFill/>
-          </a:ln>
-        </p:spPr>
-        <p:style>
-          <a:lnRef idx="1">
-            <a:schemeClr val="accent1"/>
-          </a:lnRef>
-          <a:fillRef idx="3">
-            <a:schemeClr val="accent1"/>
-          </a:fillRef>
-          <a:effectRef idx="2">
-            <a:schemeClr val="accent1"/>
-          </a:effectRef>
-          <a:fontRef idx="minor">
-            <a:schemeClr val="lt1"/>
-          </a:fontRef>
-        </p:style>
-        <p:txBody>
-          <a:bodyPr rtlCol="0" anchor="ctr"/>
-          <a:lstStyle/>
-          <a:p>
-            <a:pPr algn="ctr"/>
-          </a:p>
-        </p:txBody>
-      </p:sp>
-      <p:sp>
-        <p:nvSpPr>
-          <p:cNvPr id="7" name="Rounded Rectangle 6"/>
-          <p:cNvSpPr/>
-          <p:nvPr/>
-        </p:nvSpPr>
-        <p:spPr>
-          <a:xfrm>
-            <a:off x="777240" y="1847088"/>
-            <a:ext cx="10561320" cy="475488"/>
-          </a:xfrm>
-          <a:prstGeom prst="roundRect">
-            <a:avLst/>
-          </a:prstGeom>
-          <a:solidFill>
-            <a:srgbClr val="FFFFFF"/>
-          </a:solidFill>
-          <a:ln>
-            <a:solidFill>
-              <a:srgbClr val="E8E4DC"/>
-            </a:solidFill>
-          </a:ln>
-        </p:spPr>
-        <p:style>
-          <a:lnRef idx="1">
-            <a:schemeClr val="accent1"/>
-          </a:lnRef>
-          <a:fillRef idx="3">
-            <a:schemeClr val="accent1"/>
-          </a:fillRef>
-          <a:effectRef idx="2">
-            <a:schemeClr val="accent1"/>
-          </a:effectRef>
-          <a:fontRef idx="minor">
-            <a:schemeClr val="lt1"/>
-          </a:fontRef>
-        </p:style>
-        <p:txBody>
-          <a:bodyPr rtlCol="0" anchor="ctr"/>
-          <a:lstStyle/>
-          <a:p>
-            <a:pPr algn="ctr"/>
-          </a:p>
-        </p:txBody>
-      </p:sp>
-      <p:sp>
-        <p:nvSpPr>
-          <p:cNvPr id="8" name="TextBox 7"/>
-          <p:cNvSpPr txBox="1"/>
-          <p:nvPr/>
-        </p:nvSpPr>
-        <p:spPr>
-          <a:xfrm>
-            <a:off x="987552" y="1911096"/>
-            <a:ext cx="10104120" cy="320040"/>
-          </a:xfrm>
-          <a:prstGeom prst="rect">
-            <a:avLst/>
-          </a:prstGeom>
-          <a:noFill/>
-        </p:spPr>
-        <p:txBody>
-          <a:bodyPr wrap="none">
-            <a:spAutoFit/>
-          </a:bodyPr>
-          <a:lstStyle/>
-          <a:p>
-            <a:r>
-              <a:rPr sz="1700">
-                <a:solidFill>
-                  <a:srgbClr val="2C2C2C"/>
-                </a:solidFill>
-              </a:rPr>
-              <a:t>• migration-access-chat-pricing.sql</a:t>
-            </a:r>
-          </a:p>
-        </p:txBody>
-      </p:sp>
-      <p:sp>
-        <p:nvSpPr>
-          <p:cNvPr id="9" name="Rounded Rectangle 8"/>
-          <p:cNvSpPr/>
-          <p:nvPr/>
-        </p:nvSpPr>
-        <p:spPr>
-          <a:xfrm>
-            <a:off x="777240" y="2414016"/>
-            <a:ext cx="10561320" cy="475488"/>
-          </a:xfrm>
-          <a:prstGeom prst="roundRect">
-            <a:avLst/>
-          </a:prstGeom>
-          <a:solidFill>
-            <a:srgbClr val="FFFFFF"/>
-          </a:solidFill>
-          <a:ln>
-            <a:solidFill>
-              <a:srgbClr val="E8E4DC"/>
-            </a:solidFill>
-          </a:ln>
-        </p:spPr>
-        <p:style>
-          <a:lnRef idx="1">
-            <a:schemeClr val="accent1"/>
-          </a:lnRef>
-          <a:fillRef idx="3">
-            <a:schemeClr val="accent1"/>
-          </a:fillRef>
-          <a:effectRef idx="2">
-            <a:schemeClr val="accent1"/>
-          </a:effectRef>
-          <a:fontRef idx="minor">
-            <a:schemeClr val="lt1"/>
-          </a:fontRef>
-        </p:style>
-        <p:txBody>
-          <a:bodyPr rtlCol="0" anchor="ctr"/>
-          <a:lstStyle/>
-          <a:p>
-            <a:pPr algn="ctr"/>
-          </a:p>
-        </p:txBody>
-      </p:sp>
-      <p:sp>
-        <p:nvSpPr>
-          <p:cNvPr id="10" name="TextBox 9"/>
-          <p:cNvSpPr txBox="1"/>
-          <p:nvPr/>
-        </p:nvSpPr>
-        <p:spPr>
-          <a:xfrm>
-            <a:off x="987552" y="2478024"/>
-            <a:ext cx="10104120" cy="320040"/>
-          </a:xfrm>
-          <a:prstGeom prst="rect">
-            <a:avLst/>
-          </a:prstGeom>
-          <a:noFill/>
-        </p:spPr>
-        <p:txBody>
-          <a:bodyPr wrap="none">
-            <a:spAutoFit/>
-          </a:bodyPr>
-          <a:lstStyle/>
-          <a:p>
-            <a:r>
-              <a:rPr sz="1700">
-                <a:solidFill>
-                  <a:srgbClr val="2C2C2C"/>
-                </a:solidFill>
-              </a:rPr>
-              <a:t>• migration-company-client-fields.sql</a:t>
-            </a:r>
-          </a:p>
-        </p:txBody>
-      </p:sp>
-      <p:sp>
-        <p:nvSpPr>
-          <p:cNvPr id="11" name="Rounded Rectangle 10"/>
-          <p:cNvSpPr/>
-          <p:nvPr/>
-        </p:nvSpPr>
-        <p:spPr>
-          <a:xfrm>
-            <a:off x="777240" y="2980944"/>
-            <a:ext cx="10561320" cy="475488"/>
-          </a:xfrm>
-          <a:prstGeom prst="roundRect">
-            <a:avLst/>
-          </a:prstGeom>
-          <a:solidFill>
-            <a:srgbClr val="FFFFFF"/>
-          </a:solidFill>
-          <a:ln>
-            <a:solidFill>
-              <a:srgbClr val="E8E4DC"/>
-            </a:solidFill>
-          </a:ln>
-        </p:spPr>
-        <p:style>
-          <a:lnRef idx="1">
-            <a:schemeClr val="accent1"/>
-          </a:lnRef>
-          <a:fillRef idx="3">
-            <a:schemeClr val="accent1"/>
-          </a:fillRef>
-          <a:effectRef idx="2">
-            <a:schemeClr val="accent1"/>
-          </a:effectRef>
-          <a:fontRef idx="minor">
-            <a:schemeClr val="lt1"/>
-          </a:fontRef>
-        </p:style>
-        <p:txBody>
-          <a:bodyPr rtlCol="0" anchor="ctr"/>
-          <a:lstStyle/>
-          <a:p>
-            <a:pPr algn="ctr"/>
-          </a:p>
-        </p:txBody>
-      </p:sp>
-      <p:sp>
-        <p:nvSpPr>
-          <p:cNvPr id="12" name="TextBox 11"/>
-          <p:cNvSpPr txBox="1"/>
-          <p:nvPr/>
-        </p:nvSpPr>
-        <p:spPr>
-          <a:xfrm>
-            <a:off x="987552" y="3044952"/>
-            <a:ext cx="10104120" cy="320040"/>
-          </a:xfrm>
-          <a:prstGeom prst="rect">
-            <a:avLst/>
-          </a:prstGeom>
-          <a:noFill/>
-        </p:spPr>
-        <p:txBody>
-          <a:bodyPr wrap="none">
-            <a:spAutoFit/>
-          </a:bodyPr>
-          <a:lstStyle/>
-          <a:p>
-            <a:r>
-              <a:rPr sz="1700">
-                <a:solidFill>
-                  <a:srgbClr val="2C2C2C"/>
-                </a:solidFill>
-              </a:rPr>
-              <a:t>• migration-commercial-agents.sql</a:t>
-            </a:r>
-          </a:p>
-        </p:txBody>
-      </p:sp>
-      <p:sp>
-        <p:nvSpPr>
-          <p:cNvPr id="13" name="Rounded Rectangle 12"/>
-          <p:cNvSpPr/>
-          <p:nvPr/>
-        </p:nvSpPr>
-        <p:spPr>
-          <a:xfrm>
-            <a:off x="777240" y="3547872"/>
-            <a:ext cx="10561320" cy="475488"/>
-          </a:xfrm>
-          <a:prstGeom prst="roundRect">
-            <a:avLst/>
-          </a:prstGeom>
-          <a:solidFill>
-            <a:srgbClr val="FFFFFF"/>
-          </a:solidFill>
-          <a:ln>
-            <a:solidFill>
-              <a:srgbClr val="E8E4DC"/>
-            </a:solidFill>
-          </a:ln>
-        </p:spPr>
-        <p:style>
-          <a:lnRef idx="1">
-            <a:schemeClr val="accent1"/>
-          </a:lnRef>
-          <a:fillRef idx="3">
-            <a:schemeClr val="accent1"/>
-          </a:fillRef>
-          <a:effectRef idx="2">
-            <a:schemeClr val="accent1"/>
-          </a:effectRef>
-          <a:fontRef idx="minor">
-            <a:schemeClr val="lt1"/>
-          </a:fontRef>
-        </p:style>
-        <p:txBody>
-          <a:bodyPr rtlCol="0" anchor="ctr"/>
-          <a:lstStyle/>
-          <a:p>
-            <a:pPr algn="ctr"/>
-          </a:p>
-        </p:txBody>
-      </p:sp>
-      <p:sp>
-        <p:nvSpPr>
-          <p:cNvPr id="14" name="TextBox 13"/>
-          <p:cNvSpPr txBox="1"/>
-          <p:nvPr/>
-        </p:nvSpPr>
-        <p:spPr>
-          <a:xfrm>
-            <a:off x="987552" y="3611880"/>
-            <a:ext cx="10104120" cy="320040"/>
-          </a:xfrm>
-          <a:prstGeom prst="rect">
-            <a:avLst/>
-          </a:prstGeom>
-          <a:noFill/>
-        </p:spPr>
-        <p:txBody>
-          <a:bodyPr wrap="none">
-            <a:spAutoFit/>
-          </a:bodyPr>
-          <a:lstStyle/>
-          <a:p>
-            <a:r>
-              <a:rPr sz="1700">
-                <a:solidFill>
-                  <a:srgbClr val="2C2C2C"/>
-                </a:solidFill>
-              </a:rPr>
-              <a:t>• migration-order-delivery-tracking.sql</a:t>
-            </a:r>
-          </a:p>
-        </p:txBody>
-      </p:sp>
-      <p:sp>
-        <p:nvSpPr>
-          <p:cNvPr id="15" name="Rounded Rectangle 14"/>
-          <p:cNvSpPr/>
-          <p:nvPr/>
-        </p:nvSpPr>
-        <p:spPr>
-          <a:xfrm>
-            <a:off x="777240" y="4114800"/>
-            <a:ext cx="10561320" cy="475488"/>
-          </a:xfrm>
-          <a:prstGeom prst="roundRect">
-            <a:avLst/>
-          </a:prstGeom>
-          <a:solidFill>
-            <a:srgbClr val="FFFFFF"/>
-          </a:solidFill>
-          <a:ln>
-            <a:solidFill>
-              <a:srgbClr val="E8E4DC"/>
-            </a:solidFill>
-          </a:ln>
-        </p:spPr>
-        <p:style>
-          <a:lnRef idx="1">
-            <a:schemeClr val="accent1"/>
-          </a:lnRef>
-          <a:fillRef idx="3">
-            <a:schemeClr val="accent1"/>
-          </a:fillRef>
-          <a:effectRef idx="2">
-            <a:schemeClr val="accent1"/>
-          </a:effectRef>
-          <a:fontRef idx="minor">
-            <a:schemeClr val="lt1"/>
-          </a:fontRef>
-        </p:style>
-        <p:txBody>
-          <a:bodyPr rtlCol="0" anchor="ctr"/>
-          <a:lstStyle/>
-          <a:p>
-            <a:pPr algn="ctr"/>
-          </a:p>
-        </p:txBody>
-      </p:sp>
-      <p:sp>
-        <p:nvSpPr>
-          <p:cNvPr id="16" name="TextBox 15"/>
-          <p:cNvSpPr txBox="1"/>
-          <p:nvPr/>
-        </p:nvSpPr>
-        <p:spPr>
-          <a:xfrm>
-            <a:off x="987552" y="4178808"/>
-            <a:ext cx="10104120" cy="320040"/>
-          </a:xfrm>
-          <a:prstGeom prst="rect">
-            <a:avLst/>
-          </a:prstGeom>
-          <a:noFill/>
-        </p:spPr>
-        <p:txBody>
-          <a:bodyPr wrap="none">
-            <a:spAutoFit/>
-          </a:bodyPr>
-          <a:lstStyle/>
-          <a:p>
-            <a:r>
-              <a:rPr sz="1700">
-                <a:solidFill>
-                  <a:srgbClr val="2C2C2C"/>
-                </a:solidFill>
-              </a:rPr>
-              <a:t>• migration-suppliers.sql</a:t>
-            </a:r>
-          </a:p>
-        </p:txBody>
-      </p:sp>
-      <p:sp>
-        <p:nvSpPr>
-          <p:cNvPr id="17" name="TextBox 16"/>
-          <p:cNvSpPr txBox="1"/>
-          <p:nvPr/>
-        </p:nvSpPr>
-        <p:spPr>
-          <a:xfrm>
-            <a:off x="594360" y="6446520"/>
-            <a:ext cx="10972800" cy="228600"/>
-          </a:xfrm>
-          <a:prstGeom prst="rect">
-            <a:avLst/>
-          </a:prstGeom>
-          <a:noFill/>
-        </p:spPr>
-        <p:txBody>
-          <a:bodyPr wrap="none">
-            <a:spAutoFit/>
-          </a:bodyPr>
-          <a:lstStyle/>
-          <a:p>
-            <a:pPr algn="r"/>
-            <a:r>
-              <a:rPr sz="900">
-                <a:solidFill>
-                  <a:srgbClr val="666666"/>
-                </a:solidFill>
-              </a:rPr>
-              <a:t>Présentation HB Commerce · 13/14</a:t>
-            </a:r>
-          </a:p>
-        </p:txBody>
-      </p:sp>
-    </p:spTree>
-  </p:cSld>
-  <p:clrMapOvr>
-    <a:masterClrMapping/>
-  </p:clrMapOvr>
-</p:sld>
-</file>
-
-<file path=ppt/slides/slide14.xml><?xml version="1.0" encoding="utf-8"?>
-<p:sld xmlns:a="http://schemas.openxmlformats.org/drawingml/2006/main" xmlns:p="http://schemas.openxmlformats.org/presentationml/2006/main" xmlns:r="http://schemas.openxmlformats.org/officeDocument/2006/relationships">
-  <p:cSld>
-    <p:bg>
-      <p:bgPr>
-        <a:solidFill>
-          <a:srgbClr val="FAF8F4"/>
-        </a:solidFill>
-        <a:effectLst/>
-      </p:bgPr>
-    </p:bg>
-    <p:spTree>
-      <p:nvGrpSpPr>
-        <p:cNvPr id="1" name=""/>
-        <p:cNvGrpSpPr/>
-        <p:nvPr/>
-      </p:nvGrpSpPr>
-      <p:grpSpPr/>
-      <p:sp>
-        <p:nvSpPr>
-          <p:cNvPr id="2" name="Rectangle 1"/>
-          <p:cNvSpPr/>
-          <p:nvPr/>
-        </p:nvSpPr>
-        <p:spPr>
-          <a:xfrm>
-            <a:off x="0" y="0"/>
-            <a:ext cx="12191695" cy="566928"/>
-          </a:xfrm>
-          <a:prstGeom prst="rect">
-            <a:avLst/>
-          </a:prstGeom>
-          <a:solidFill>
-            <a:srgbClr val="0F3D32"/>
-          </a:solidFill>
-          <a:ln>
-            <a:noFill/>
-          </a:ln>
-        </p:spPr>
-        <p:style>
-          <a:lnRef idx="1">
-            <a:schemeClr val="accent1"/>
-          </a:lnRef>
-          <a:fillRef idx="3">
-            <a:schemeClr val="accent1"/>
-          </a:fillRef>
-          <a:effectRef idx="2">
-            <a:schemeClr val="accent1"/>
-          </a:effectRef>
-          <a:fontRef idx="minor">
-            <a:schemeClr val="lt1"/>
-          </a:fontRef>
-        </p:style>
-        <p:txBody>
-          <a:bodyPr rtlCol="0" anchor="ctr"/>
-          <a:lstStyle/>
-          <a:p>
-            <a:pPr algn="ctr"/>
-          </a:p>
-        </p:txBody>
-      </p:sp>
-      <p:pic>
-        <p:nvPicPr>
-          <p:cNvPr id="3" name="Picture 2" descr="hb-commerce-logo.png"/>
-          <p:cNvPicPr>
-            <a:picLocks noChangeAspect="1"/>
-          </p:cNvPicPr>
-          <p:nvPr/>
-        </p:nvPicPr>
-        <p:blipFill>
-          <a:blip r:embed="rId2"/>
-          <a:stretch>
-            <a:fillRect/>
-          </a:stretch>
-        </p:blipFill>
-        <p:spPr>
-          <a:xfrm>
-            <a:off x="320040" y="100584"/>
-            <a:ext cx="2148840" cy="429768"/>
-          </a:xfrm>
-          <a:prstGeom prst="rect">
-            <a:avLst/>
-          </a:prstGeom>
-        </p:spPr>
-      </p:pic>
-      <p:sp>
-        <p:nvSpPr>
-          <p:cNvPr id="4" name="TextBox 3"/>
-          <p:cNvSpPr txBox="1"/>
-          <p:nvPr/>
-        </p:nvSpPr>
-        <p:spPr>
-          <a:xfrm>
-            <a:off x="9464040" y="155448"/>
-            <a:ext cx="2331720" cy="274320"/>
-          </a:xfrm>
-          <a:prstGeom prst="rect">
-            <a:avLst/>
-          </a:prstGeom>
-          <a:noFill/>
-        </p:spPr>
-        <p:txBody>
-          <a:bodyPr wrap="none">
-            <a:spAutoFit/>
-          </a:bodyPr>
-          <a:lstStyle/>
-          <a:p>
-            <a:pPr algn="r"/>
-            <a:r>
-              <a:rPr sz="1200" b="1">
-                <a:solidFill>
-                  <a:srgbClr val="FFFFFF"/>
-                </a:solidFill>
-              </a:rPr>
-              <a:t>HB Commerce</a:t>
-            </a:r>
-          </a:p>
-        </p:txBody>
-      </p:sp>
-      <p:sp>
-        <p:nvSpPr>
-          <p:cNvPr id="5" name="TextBox 4"/>
-          <p:cNvSpPr txBox="1"/>
-          <p:nvPr/>
-        </p:nvSpPr>
-        <p:spPr>
-          <a:xfrm>
-            <a:off x="594360" y="868680"/>
-            <a:ext cx="10789920" cy="640080"/>
-          </a:xfrm>
-          <a:prstGeom prst="rect">
-            <a:avLst/>
-          </a:prstGeom>
-          <a:noFill/>
-        </p:spPr>
-        <p:txBody>
-          <a:bodyPr wrap="none">
-            <a:spAutoFit/>
-          </a:bodyPr>
-          <a:lstStyle/>
-          <a:p>
-            <a:r>
-              <a:rPr sz="3200" b="1">
-                <a:solidFill>
-                  <a:srgbClr val="0F3D32"/>
-                </a:solidFill>
-              </a:rPr>
-              <a:t>Prochaines étapes</a:t>
-            </a:r>
-          </a:p>
-        </p:txBody>
-      </p:sp>
-      <p:sp>
-        <p:nvSpPr>
-          <p:cNvPr id="6" name="Rectangle 5"/>
-          <p:cNvSpPr/>
-          <p:nvPr/>
-        </p:nvSpPr>
-        <p:spPr>
-          <a:xfrm>
-            <a:off x="594360" y="1536192"/>
-            <a:ext cx="1874519" cy="54864"/>
-          </a:xfrm>
-          <a:prstGeom prst="rect">
-            <a:avLst/>
-          </a:prstGeom>
-          <a:solidFill>
-            <a:srgbClr val="C9A227"/>
-          </a:solidFill>
-          <a:ln>
-            <a:noFill/>
-          </a:ln>
-        </p:spPr>
-        <p:style>
-          <a:lnRef idx="1">
-            <a:schemeClr val="accent1"/>
-          </a:lnRef>
-          <a:fillRef idx="3">
-            <a:schemeClr val="accent1"/>
-          </a:fillRef>
-          <a:effectRef idx="2">
-            <a:schemeClr val="accent1"/>
-          </a:effectRef>
-          <a:fontRef idx="minor">
-            <a:schemeClr val="lt1"/>
-          </a:fontRef>
-        </p:style>
-        <p:txBody>
-          <a:bodyPr rtlCol="0" anchor="ctr"/>
-          <a:lstStyle/>
-          <a:p>
-            <a:pPr algn="ctr"/>
-          </a:p>
-        </p:txBody>
-      </p:sp>
-      <p:sp>
-        <p:nvSpPr>
-          <p:cNvPr id="7" name="Rounded Rectangle 6"/>
-          <p:cNvSpPr/>
-          <p:nvPr/>
-        </p:nvSpPr>
-        <p:spPr>
-          <a:xfrm>
-            <a:off x="777240" y="1847088"/>
-            <a:ext cx="10561320" cy="475488"/>
-          </a:xfrm>
-          <a:prstGeom prst="roundRect">
-            <a:avLst/>
-          </a:prstGeom>
-          <a:solidFill>
-            <a:srgbClr val="FFFFFF"/>
-          </a:solidFill>
-          <a:ln>
-            <a:solidFill>
-              <a:srgbClr val="E8E4DC"/>
-            </a:solidFill>
-          </a:ln>
-        </p:spPr>
-        <p:style>
-          <a:lnRef idx="1">
-            <a:schemeClr val="accent1"/>
-          </a:lnRef>
-          <a:fillRef idx="3">
-            <a:schemeClr val="accent1"/>
-          </a:fillRef>
-          <a:effectRef idx="2">
-            <a:schemeClr val="accent1"/>
-          </a:effectRef>
-          <a:fontRef idx="minor">
-            <a:schemeClr val="lt1"/>
-          </a:fontRef>
-        </p:style>
-        <p:txBody>
-          <a:bodyPr rtlCol="0" anchor="ctr"/>
-          <a:lstStyle/>
-          <a:p>
-            <a:pPr algn="ctr"/>
-          </a:p>
-        </p:txBody>
-      </p:sp>
-      <p:sp>
-        <p:nvSpPr>
-          <p:cNvPr id="8" name="TextBox 7"/>
-          <p:cNvSpPr txBox="1"/>
-          <p:nvPr/>
-        </p:nvSpPr>
-        <p:spPr>
-          <a:xfrm>
-            <a:off x="987552" y="1911096"/>
-            <a:ext cx="10104120" cy="320040"/>
-          </a:xfrm>
-          <a:prstGeom prst="rect">
-            <a:avLst/>
-          </a:prstGeom>
-          <a:noFill/>
-        </p:spPr>
-        <p:txBody>
-          <a:bodyPr wrap="none">
-            <a:spAutoFit/>
-          </a:bodyPr>
-          <a:lstStyle/>
-          <a:p>
-            <a:r>
-              <a:rPr sz="1700">
-                <a:solidFill>
-                  <a:srgbClr val="2C2C2C"/>
-                </a:solidFill>
-              </a:rPr>
-              <a:t>• Exécuter les migrations sur Supabase</a:t>
-            </a:r>
-          </a:p>
-        </p:txBody>
-      </p:sp>
-      <p:sp>
-        <p:nvSpPr>
-          <p:cNvPr id="9" name="Rounded Rectangle 8"/>
-          <p:cNvSpPr/>
-          <p:nvPr/>
-        </p:nvSpPr>
-        <p:spPr>
-          <a:xfrm>
-            <a:off x="777240" y="2414016"/>
-            <a:ext cx="10561320" cy="475488"/>
-          </a:xfrm>
-          <a:prstGeom prst="roundRect">
-            <a:avLst/>
-          </a:prstGeom>
-          <a:solidFill>
-            <a:srgbClr val="FFFFFF"/>
-          </a:solidFill>
-          <a:ln>
-            <a:solidFill>
-              <a:srgbClr val="E8E4DC"/>
-            </a:solidFill>
-          </a:ln>
-        </p:spPr>
-        <p:style>
-          <a:lnRef idx="1">
-            <a:schemeClr val="accent1"/>
-          </a:lnRef>
-          <a:fillRef idx="3">
-            <a:schemeClr val="accent1"/>
-          </a:fillRef>
-          <a:effectRef idx="2">
-            <a:schemeClr val="accent1"/>
-          </a:effectRef>
-          <a:fontRef idx="minor">
-            <a:schemeClr val="lt1"/>
-          </a:fontRef>
-        </p:style>
-        <p:txBody>
-          <a:bodyPr rtlCol="0" anchor="ctr"/>
-          <a:lstStyle/>
-          <a:p>
-            <a:pPr algn="ctr"/>
-          </a:p>
-        </p:txBody>
-      </p:sp>
-      <p:sp>
-        <p:nvSpPr>
-          <p:cNvPr id="10" name="TextBox 9"/>
-          <p:cNvSpPr txBox="1"/>
-          <p:nvPr/>
-        </p:nvSpPr>
-        <p:spPr>
-          <a:xfrm>
-            <a:off x="987552" y="2478024"/>
-            <a:ext cx="10104120" cy="320040"/>
-          </a:xfrm>
-          <a:prstGeom prst="rect">
-            <a:avLst/>
-          </a:prstGeom>
-          <a:noFill/>
-        </p:spPr>
-        <p:txBody>
-          <a:bodyPr wrap="none">
-            <a:spAutoFit/>
-          </a:bodyPr>
-          <a:lstStyle/>
-          <a:p>
-            <a:r>
-              <a:rPr sz="1700">
-                <a:solidFill>
-                  <a:srgbClr val="2C2C2C"/>
-                </a:solidFill>
-              </a:rPr>
-              <a:t>• Créer/valider le compte super root</a:t>
-            </a:r>
-          </a:p>
-        </p:txBody>
-      </p:sp>
-      <p:sp>
-        <p:nvSpPr>
-          <p:cNvPr id="11" name="Rounded Rectangle 10"/>
-          <p:cNvSpPr/>
-          <p:nvPr/>
-        </p:nvSpPr>
-        <p:spPr>
-          <a:xfrm>
-            <a:off x="777240" y="2980944"/>
-            <a:ext cx="10561320" cy="475488"/>
-          </a:xfrm>
-          <a:prstGeom prst="roundRect">
-            <a:avLst/>
-          </a:prstGeom>
-          <a:solidFill>
-            <a:srgbClr val="FFFFFF"/>
-          </a:solidFill>
-          <a:ln>
-            <a:solidFill>
-              <a:srgbClr val="E8E4DC"/>
-            </a:solidFill>
-          </a:ln>
-        </p:spPr>
-        <p:style>
-          <a:lnRef idx="1">
-            <a:schemeClr val="accent1"/>
-          </a:lnRef>
-          <a:fillRef idx="3">
-            <a:schemeClr val="accent1"/>
-          </a:fillRef>
-          <a:effectRef idx="2">
-            <a:schemeClr val="accent1"/>
-          </a:effectRef>
-          <a:fontRef idx="minor">
-            <a:schemeClr val="lt1"/>
-          </a:fontRef>
-        </p:style>
-        <p:txBody>
-          <a:bodyPr rtlCol="0" anchor="ctr"/>
-          <a:lstStyle/>
-          <a:p>
-            <a:pPr algn="ctr"/>
-          </a:p>
-        </p:txBody>
-      </p:sp>
-      <p:sp>
-        <p:nvSpPr>
-          <p:cNvPr id="12" name="TextBox 11"/>
-          <p:cNvSpPr txBox="1"/>
-          <p:nvPr/>
-        </p:nvSpPr>
-        <p:spPr>
-          <a:xfrm>
-            <a:off x="987552" y="3044952"/>
-            <a:ext cx="10104120" cy="320040"/>
-          </a:xfrm>
-          <a:prstGeom prst="rect">
-            <a:avLst/>
-          </a:prstGeom>
-          <a:noFill/>
-        </p:spPr>
-        <p:txBody>
-          <a:bodyPr wrap="none">
-            <a:spAutoFit/>
-          </a:bodyPr>
-          <a:lstStyle/>
-          <a:p>
-            <a:r>
-              <a:rPr sz="1700">
-                <a:solidFill>
-                  <a:srgbClr val="2C2C2C"/>
-                </a:solidFill>
-              </a:rPr>
-              <a:t>• Créer agents et fournisseurs</a:t>
-            </a:r>
-          </a:p>
-        </p:txBody>
-      </p:sp>
-      <p:sp>
-        <p:nvSpPr>
-          <p:cNvPr id="13" name="Rounded Rectangle 12"/>
-          <p:cNvSpPr/>
-          <p:nvPr/>
-        </p:nvSpPr>
-        <p:spPr>
-          <a:xfrm>
-            <a:off x="777240" y="3547872"/>
-            <a:ext cx="10561320" cy="475488"/>
-          </a:xfrm>
-          <a:prstGeom prst="roundRect">
-            <a:avLst/>
-          </a:prstGeom>
-          <a:solidFill>
-            <a:srgbClr val="FFFFFF"/>
-          </a:solidFill>
-          <a:ln>
-            <a:solidFill>
-              <a:srgbClr val="E8E4DC"/>
-            </a:solidFill>
-          </a:ln>
-        </p:spPr>
-        <p:style>
-          <a:lnRef idx="1">
-            <a:schemeClr val="accent1"/>
-          </a:lnRef>
-          <a:fillRef idx="3">
-            <a:schemeClr val="accent1"/>
-          </a:fillRef>
-          <a:effectRef idx="2">
-            <a:schemeClr val="accent1"/>
-          </a:effectRef>
-          <a:fontRef idx="minor">
-            <a:schemeClr val="lt1"/>
-          </a:fontRef>
-        </p:style>
-        <p:txBody>
-          <a:bodyPr rtlCol="0" anchor="ctr"/>
-          <a:lstStyle/>
-          <a:p>
-            <a:pPr algn="ctr"/>
-          </a:p>
-        </p:txBody>
-      </p:sp>
-      <p:sp>
-        <p:nvSpPr>
-          <p:cNvPr id="14" name="TextBox 13"/>
-          <p:cNvSpPr txBox="1"/>
-          <p:nvPr/>
-        </p:nvSpPr>
-        <p:spPr>
-          <a:xfrm>
-            <a:off x="987552" y="3611880"/>
-            <a:ext cx="10104120" cy="320040"/>
-          </a:xfrm>
-          <a:prstGeom prst="rect">
-            <a:avLst/>
-          </a:prstGeom>
-          <a:noFill/>
-        </p:spPr>
-        <p:txBody>
-          <a:bodyPr wrap="none">
-            <a:spAutoFit/>
-          </a:bodyPr>
-          <a:lstStyle/>
-          <a:p>
-            <a:r>
-              <a:rPr sz="1700">
-                <a:solidFill>
-                  <a:srgbClr val="2C2C2C"/>
-                </a:solidFill>
-              </a:rPr>
-              <a:t>• Assigner agents et fournisseurs</a:t>
-            </a:r>
-          </a:p>
-        </p:txBody>
-      </p:sp>
-      <p:sp>
-        <p:nvSpPr>
-          <p:cNvPr id="15" name="Rounded Rectangle 14"/>
-          <p:cNvSpPr/>
-          <p:nvPr/>
-        </p:nvSpPr>
-        <p:spPr>
-          <a:xfrm>
-            <a:off x="777240" y="4114800"/>
-            <a:ext cx="10561320" cy="475488"/>
-          </a:xfrm>
-          <a:prstGeom prst="roundRect">
-            <a:avLst/>
-          </a:prstGeom>
-          <a:solidFill>
-            <a:srgbClr val="FFFFFF"/>
-          </a:solidFill>
-          <a:ln>
-            <a:solidFill>
-              <a:srgbClr val="E8E4DC"/>
-            </a:solidFill>
-          </a:ln>
-        </p:spPr>
-        <p:style>
-          <a:lnRef idx="1">
-            <a:schemeClr val="accent1"/>
-          </a:lnRef>
-          <a:fillRef idx="3">
-            <a:schemeClr val="accent1"/>
-          </a:fillRef>
-          <a:effectRef idx="2">
-            <a:schemeClr val="accent1"/>
-          </a:effectRef>
-          <a:fontRef idx="minor">
-            <a:schemeClr val="lt1"/>
-          </a:fontRef>
-        </p:style>
-        <p:txBody>
-          <a:bodyPr rtlCol="0" anchor="ctr"/>
-          <a:lstStyle/>
-          <a:p>
-            <a:pPr algn="ctr"/>
-          </a:p>
-        </p:txBody>
-      </p:sp>
-      <p:sp>
-        <p:nvSpPr>
-          <p:cNvPr id="16" name="TextBox 15"/>
-          <p:cNvSpPr txBox="1"/>
-          <p:nvPr/>
-        </p:nvSpPr>
-        <p:spPr>
-          <a:xfrm>
-            <a:off x="987552" y="4178808"/>
-            <a:ext cx="10104120" cy="320040"/>
-          </a:xfrm>
-          <a:prstGeom prst="rect">
-            <a:avLst/>
-          </a:prstGeom>
-          <a:noFill/>
-        </p:spPr>
-        <p:txBody>
-          <a:bodyPr wrap="none">
-            <a:spAutoFit/>
-          </a:bodyPr>
-          <a:lstStyle/>
-          <a:p>
-            <a:r>
-              <a:rPr sz="1700">
-                <a:solidFill>
-                  <a:srgbClr val="2C2C2C"/>
-                </a:solidFill>
-              </a:rPr>
-              <a:t>• Tester un cycle complet : stock → commande → paiement → livraison → facture</a:t>
-            </a:r>
-          </a:p>
-        </p:txBody>
-      </p:sp>
-      <p:sp>
-        <p:nvSpPr>
-          <p:cNvPr id="17" name="TextBox 16"/>
-          <p:cNvSpPr txBox="1"/>
-          <p:nvPr/>
-        </p:nvSpPr>
-        <p:spPr>
-          <a:xfrm>
-            <a:off x="594360" y="6446520"/>
-            <a:ext cx="10972800" cy="228600"/>
-          </a:xfrm>
-          <a:prstGeom prst="rect">
-            <a:avLst/>
-          </a:prstGeom>
-          <a:noFill/>
-        </p:spPr>
-        <p:txBody>
-          <a:bodyPr wrap="none">
-            <a:spAutoFit/>
-          </a:bodyPr>
-          <a:lstStyle/>
-          <a:p>
-            <a:pPr algn="r"/>
-            <a:r>
-              <a:rPr sz="900">
-                <a:solidFill>
-                  <a:srgbClr val="666666"/>
-                </a:solidFill>
-              </a:rPr>
-              <a:t>Présentation HB Commerce · 14/14</a:t>
+              <a:t>Présentation HB Commerce · 12/12</a:t>
             </a:r>
           </a:p>
         </p:txBody>
@@ -6760,7 +5504,7 @@
       </p:sp>
       <p:pic>
         <p:nvPicPr>
-          <p:cNvPr id="3" name="Picture 2" descr="hb-commerce-logo.png"/>
+          <p:cNvPr id="3" name="Picture 2" descr="hb-commerce-logo-temp.png"/>
           <p:cNvPicPr>
             <a:picLocks noChangeAspect="1"/>
           </p:cNvPicPr>
@@ -6790,8 +5534,8 @@
         </p:nvSpPr>
         <p:spPr>
           <a:xfrm>
-            <a:off x="9464040" y="155448"/>
-            <a:ext cx="2331720" cy="274320"/>
+            <a:off x="9326880" y="155448"/>
+            <a:ext cx="2560320" cy="274320"/>
           </a:xfrm>
           <a:prstGeom prst="rect">
             <a:avLst/>
@@ -6844,7 +5588,7 @@
                   <a:srgbClr val="0F3D32"/>
                 </a:solidFill>
               </a:rPr>
-              <a:t>Vision &amp; objectifs</a:t>
+              <a:t>Vision du projet</a:t>
             </a:r>
           </a:p>
         </p:txBody>
@@ -6965,7 +5709,7 @@
                   <a:srgbClr val="2C2C2C"/>
                 </a:solidFill>
               </a:rPr>
-              <a:t>• Digitaliser la vente en gros FIAFI</a:t>
+              <a:t>• Commerce B2B FIAFI</a:t>
             </a:r>
           </a:p>
         </p:txBody>
@@ -7043,7 +5787,7 @@
                   <a:srgbClr val="2C2C2C"/>
                 </a:solidFill>
               </a:rPr>
-              <a:t>• Centraliser clients, commandes et prix personnalisés</a:t>
+              <a:t>• Pilotage clients, fournisseurs, agents et stock</a:t>
             </a:r>
           </a:p>
         </p:txBody>
@@ -7121,7 +5865,7 @@
                   <a:srgbClr val="2C2C2C"/>
                 </a:solidFill>
               </a:rPr>
-              <a:t>• Piloter fournisseurs, stock et délais</a:t>
+              <a:t>• Traçabilité commandes, factures et livraison</a:t>
             </a:r>
           </a:p>
         </p:txBody>
@@ -7199,7 +5943,7 @@
                   <a:srgbClr val="2C2C2C"/>
                 </a:solidFill>
               </a:rPr>
-              <a:t>• Tracer factures, livraison et historique complet</a:t>
+              <a:t>• Back-office par rôle sécurisé</a:t>
             </a:r>
           </a:p>
         </p:txBody>
@@ -7233,7 +5977,7 @@
                   <a:srgbClr val="666666"/>
                 </a:solidFill>
               </a:rPr>
-              <a:t>Présentation HB Commerce · 2/14</a:t>
+              <a:t>Présentation HB Commerce · 2/12</a:t>
             </a:r>
           </a:p>
         </p:txBody>
@@ -7309,7 +6053,7 @@
       </p:sp>
       <p:pic>
         <p:nvPicPr>
-          <p:cNvPr id="3" name="Picture 2" descr="hb-commerce-logo.png"/>
+          <p:cNvPr id="3" name="Picture 2" descr="hb-commerce-logo-temp.png"/>
           <p:cNvPicPr>
             <a:picLocks noChangeAspect="1"/>
           </p:cNvPicPr>
@@ -7339,8 +6083,8 @@
         </p:nvSpPr>
         <p:spPr>
           <a:xfrm>
-            <a:off x="9464040" y="155448"/>
-            <a:ext cx="2331720" cy="274320"/>
+            <a:off x="9326880" y="155448"/>
+            <a:ext cx="2560320" cy="274320"/>
           </a:xfrm>
           <a:prstGeom prst="rect">
             <a:avLst/>
@@ -7393,7 +6137,7 @@
                   <a:srgbClr val="0F3D32"/>
                 </a:solidFill>
               </a:rPr>
-              <a:t>Rôles de la plateforme</a:t>
+              <a:t>Création des comptes</a:t>
             </a:r>
           </a:p>
         </p:txBody>
@@ -7514,7 +6258,7 @@
                   <a:srgbClr val="2C2C2C"/>
                 </a:solidFill>
               </a:rPr>
-              <a:t>• Client société : commande, chat, factures, suivi</a:t>
+              <a:t>• Créer société client / fournisseur</a:t>
             </a:r>
           </a:p>
         </p:txBody>
@@ -7592,7 +6336,7 @@
                   <a:srgbClr val="2C2C2C"/>
                 </a:solidFill>
               </a:rPr>
-              <a:t>• Agent commercial : portefeuille client assigné</a:t>
+              <a:t>• Inscription en ligne = société en attente</a:t>
             </a:r>
           </a:p>
         </p:txBody>
@@ -7670,7 +6414,7 @@
                   <a:srgbClr val="2C2C2C"/>
                 </a:solidFill>
               </a:rPr>
-              <a:t>• Admin HB Commerce : opérations et validation</a:t>
+              <a:t>• Admin/super root affecte client ou fournisseur</a:t>
             </a:r>
           </a:p>
         </p:txBody>
@@ -7748,66 +6492,21 @@
                   <a:srgbClr val="2C2C2C"/>
                 </a:solidFill>
               </a:rPr>
-              <a:t>• Super root : gouvernance et accès</a:t>
-            </a:r>
-          </a:p>
-        </p:txBody>
-      </p:sp>
-      <p:sp>
-        <p:nvSpPr>
-          <p:cNvPr id="15" name="Rounded Rectangle 14"/>
-          <p:cNvSpPr/>
-          <p:nvPr/>
-        </p:nvSpPr>
-        <p:spPr>
-          <a:xfrm>
-            <a:off x="777240" y="4114800"/>
-            <a:ext cx="10561320" cy="475488"/>
-          </a:xfrm>
-          <a:prstGeom prst="roundRect">
-            <a:avLst/>
-          </a:prstGeom>
-          <a:solidFill>
-            <a:srgbClr val="FFFFFF"/>
-          </a:solidFill>
-          <a:ln>
-            <a:solidFill>
-              <a:srgbClr val="E8E4DC"/>
-            </a:solidFill>
-          </a:ln>
-        </p:spPr>
-        <p:style>
-          <a:lnRef idx="1">
-            <a:schemeClr val="accent1"/>
-          </a:lnRef>
-          <a:fillRef idx="3">
-            <a:schemeClr val="accent1"/>
-          </a:fillRef>
-          <a:effectRef idx="2">
-            <a:schemeClr val="accent1"/>
-          </a:effectRef>
-          <a:fontRef idx="minor">
-            <a:schemeClr val="lt1"/>
-          </a:fontRef>
-        </p:style>
-        <p:txBody>
-          <a:bodyPr rtlCol="0" anchor="ctr"/>
-          <a:lstStyle/>
-          <a:p>
-            <a:pPr algn="ctr"/>
-          </a:p>
-        </p:txBody>
-      </p:sp>
-      <p:sp>
-        <p:nvSpPr>
-          <p:cNvPr id="16" name="TextBox 15"/>
+              <a:t>• Créer utilisateur interne HB Commerce séparément</a:t>
+            </a:r>
+          </a:p>
+        </p:txBody>
+      </p:sp>
+      <p:sp>
+        <p:nvSpPr>
+          <p:cNvPr id="15" name="TextBox 14"/>
           <p:cNvSpPr txBox="1"/>
           <p:nvPr/>
         </p:nvSpPr>
         <p:spPr>
           <a:xfrm>
-            <a:off x="987552" y="4178808"/>
-            <a:ext cx="10104120" cy="320040"/>
+            <a:off x="594360" y="6446520"/>
+            <a:ext cx="10972800" cy="228600"/>
           </a:xfrm>
           <a:prstGeom prst="rect">
             <a:avLst/>
@@ -7820,47 +6519,14 @@
           </a:bodyPr>
           <a:lstStyle/>
           <a:p>
-            <a:r>
-              <a:rPr sz="1700">
-                <a:solidFill>
-                  <a:srgbClr val="2C2C2C"/>
+            <a:pPr algn="r"/>
+            <a:r>
+              <a:rPr sz="900">
+                <a:solidFill>
+                  <a:srgbClr val="666666"/>
                 </a:solidFill>
               </a:rPr>
-              <a:t>• Fournisseur : stock et approvisionnement</a:t>
-            </a:r>
-          </a:p>
-        </p:txBody>
-      </p:sp>
-      <p:sp>
-        <p:nvSpPr>
-          <p:cNvPr id="17" name="TextBox 16"/>
-          <p:cNvSpPr txBox="1"/>
-          <p:nvPr/>
-        </p:nvSpPr>
-        <p:spPr>
-          <a:xfrm>
-            <a:off x="594360" y="6446520"/>
-            <a:ext cx="10972800" cy="228600"/>
-          </a:xfrm>
-          <a:prstGeom prst="rect">
-            <a:avLst/>
-          </a:prstGeom>
-          <a:noFill/>
-        </p:spPr>
-        <p:txBody>
-          <a:bodyPr wrap="none">
-            <a:spAutoFit/>
-          </a:bodyPr>
-          <a:lstStyle/>
-          <a:p>
-            <a:pPr algn="r"/>
-            <a:r>
-              <a:rPr sz="900">
-                <a:solidFill>
-                  <a:srgbClr val="666666"/>
-                </a:solidFill>
-              </a:rPr>
-              <a:t>Présentation HB Commerce · 3/14</a:t>
+              <a:t>Présentation HB Commerce · 3/12</a:t>
             </a:r>
           </a:p>
         </p:txBody>
@@ -7936,7 +6602,7 @@
       </p:sp>
       <p:pic>
         <p:nvPicPr>
-          <p:cNvPr id="3" name="Picture 2" descr="hb-commerce-logo.png"/>
+          <p:cNvPr id="3" name="Picture 2" descr="hb-commerce-logo-temp.png"/>
           <p:cNvPicPr>
             <a:picLocks noChangeAspect="1"/>
           </p:cNvPicPr>
@@ -7966,8 +6632,8 @@
         </p:nvSpPr>
         <p:spPr>
           <a:xfrm>
-            <a:off x="9464040" y="155448"/>
-            <a:ext cx="2331720" cy="274320"/>
+            <a:off x="9326880" y="155448"/>
+            <a:ext cx="2560320" cy="274320"/>
           </a:xfrm>
           <a:prstGeom prst="rect">
             <a:avLst/>
@@ -8020,7 +6686,7 @@
                   <a:srgbClr val="0F3D32"/>
                 </a:solidFill>
               </a:rPr>
-              <a:t>Parcours client société</a:t>
+              <a:t>Utilisateurs internes HB Commerce</a:t>
             </a:r>
           </a:p>
         </p:txBody>
@@ -8141,7 +6807,7 @@
                   <a:srgbClr val="2C2C2C"/>
                 </a:solidFill>
               </a:rPr>
-              <a:t>• Inscription ou création par back-office</a:t>
+              <a:t>• Agent commercial</a:t>
             </a:r>
           </a:p>
         </p:txBody>
@@ -8219,7 +6885,7 @@
                   <a:srgbClr val="2C2C2C"/>
                 </a:solidFill>
               </a:rPr>
-              <a:t>• Rôle client imposé à la création</a:t>
+              <a:t>• Admin</a:t>
             </a:r>
           </a:p>
         </p:txBody>
@@ -8297,7 +6963,7 @@
                   <a:srgbClr val="2C2C2C"/>
                 </a:solidFill>
               </a:rPr>
-              <a:t>• SIREN, TVA, adresse et contact obligatoires</a:t>
+              <a:t>• Super root</a:t>
             </a:r>
           </a:p>
         </p:txBody>
@@ -8375,7 +7041,7 @@
                   <a:srgbClr val="2C2C2C"/>
                 </a:solidFill>
               </a:rPr>
-              <a:t>• Prix personnalisés après connexion</a:t>
+              <a:t>• Aucune saisie société/SIREN/TVA/adresse</a:t>
             </a:r>
           </a:p>
         </p:txBody>
@@ -8453,7 +7119,7 @@
                   <a:srgbClr val="2C2C2C"/>
                 </a:solidFill>
               </a:rPr>
-              <a:t>• Historique complet des commandes</a:t>
+              <a:t>• Rattachement automatique à HB Commerce</a:t>
             </a:r>
           </a:p>
         </p:txBody>
@@ -8487,7 +7153,7 @@
                   <a:srgbClr val="666666"/>
                 </a:solidFill>
               </a:rPr>
-              <a:t>Présentation HB Commerce · 4/14</a:t>
+              <a:t>Présentation HB Commerce · 4/12</a:t>
             </a:r>
           </a:p>
         </p:txBody>
@@ -8563,7 +7229,7 @@
       </p:sp>
       <p:pic>
         <p:nvPicPr>
-          <p:cNvPr id="3" name="Picture 2" descr="hb-commerce-logo.png"/>
+          <p:cNvPr id="3" name="Picture 2" descr="hb-commerce-logo-temp.png"/>
           <p:cNvPicPr>
             <a:picLocks noChangeAspect="1"/>
           </p:cNvPicPr>
@@ -8593,8 +7259,8 @@
         </p:nvSpPr>
         <p:spPr>
           <a:xfrm>
-            <a:off x="9464040" y="155448"/>
-            <a:ext cx="2331720" cy="274320"/>
+            <a:off x="9326880" y="155448"/>
+            <a:ext cx="2560320" cy="274320"/>
           </a:xfrm>
           <a:prstGeom prst="rect">
             <a:avLst/>
@@ -8647,7 +7313,7 @@
                   <a:srgbClr val="0F3D32"/>
                 </a:solidFill>
               </a:rPr>
-              <a:t>Agent commercial</a:t>
+              <a:t>Clients sociétés</a:t>
             </a:r>
           </a:p>
         </p:txBody>
@@ -8768,7 +7434,7 @@
                   <a:srgbClr val="2C2C2C"/>
                 </a:solidFill>
               </a:rPr>
-              <a:t>• Assigné à des clients précis</a:t>
+              <a:t>• SIREN, TVA, adresse, contact obligatoires</a:t>
             </a:r>
           </a:p>
         </p:txBody>
@@ -8846,7 +7512,7 @@
                   <a:srgbClr val="2C2C2C"/>
                 </a:solidFill>
               </a:rPr>
-              <a:t>• Valide et suit les commandes de ses clients</a:t>
+              <a:t>• Prix personnalisés</a:t>
             </a:r>
           </a:p>
         </p:txBody>
@@ -8924,7 +7590,7 @@
                   <a:srgbClr val="2C2C2C"/>
                 </a:solidFill>
               </a:rPr>
-              <a:t>• Échange via chat pour finaliser les commandes</a:t>
+              <a:t>• Historique complet</a:t>
             </a:r>
           </a:p>
         </p:txBody>
@@ -9002,7 +7668,7 @@
                   <a:srgbClr val="2C2C2C"/>
                 </a:solidFill>
               </a:rPr>
-              <a:t>• Fixe les prix personnalisés de son portefeuille</a:t>
+              <a:t>• Factures téléchargeables</a:t>
             </a:r>
           </a:p>
         </p:txBody>
@@ -9080,7 +7746,7 @@
                   <a:srgbClr val="2C2C2C"/>
                 </a:solidFill>
               </a:rPr>
-              <a:t>• Admin et super root sont assignables comme agents par défaut</a:t>
+              <a:t>• Suivi livraison</a:t>
             </a:r>
           </a:p>
         </p:txBody>
@@ -9114,7 +7780,7 @@
                   <a:srgbClr val="666666"/>
                 </a:solidFill>
               </a:rPr>
-              <a:t>Présentation HB Commerce · 5/14</a:t>
+              <a:t>Présentation HB Commerce · 5/12</a:t>
             </a:r>
           </a:p>
         </p:txBody>
@@ -9190,7 +7856,7 @@
       </p:sp>
       <p:pic>
         <p:nvPicPr>
-          <p:cNvPr id="3" name="Picture 2" descr="hb-commerce-logo.png"/>
+          <p:cNvPr id="3" name="Picture 2" descr="hb-commerce-logo-temp.png"/>
           <p:cNvPicPr>
             <a:picLocks noChangeAspect="1"/>
           </p:cNvPicPr>
@@ -9220,8 +7886,8 @@
         </p:nvSpPr>
         <p:spPr>
           <a:xfrm>
-            <a:off x="9464040" y="155448"/>
-            <a:ext cx="2331720" cy="274320"/>
+            <a:off x="9326880" y="155448"/>
+            <a:ext cx="2560320" cy="274320"/>
           </a:xfrm>
           <a:prstGeom prst="rect">
             <a:avLst/>
@@ -9274,7 +7940,7 @@
                   <a:srgbClr val="0F3D32"/>
                 </a:solidFill>
               </a:rPr>
-              <a:t>Dashboard admin</a:t>
+              <a:t>Agents commerciaux</a:t>
             </a:r>
           </a:p>
         </p:txBody>
@@ -9395,7 +8061,7 @@
                   <a:srgbClr val="2C2C2C"/>
                 </a:solidFill>
               </a:rPr>
-              <a:t>• Gestion produits et fournisseurs</a:t>
+              <a:t>• Assignation à des clients</a:t>
             </a:r>
           </a:p>
         </p:txBody>
@@ -9473,7 +8139,7 @@
                   <a:srgbClr val="2C2C2C"/>
                 </a:solidFill>
               </a:rPr>
-              <a:t>• Création clients et agents commerciaux</a:t>
+              <a:t>• Admin et super root assignables par défaut</a:t>
             </a:r>
           </a:p>
         </p:txBody>
@@ -9551,7 +8217,7 @@
                   <a:srgbClr val="2C2C2C"/>
                 </a:solidFill>
               </a:rPr>
-              <a:t>• Affectation agent ↔ client</a:t>
+              <a:t>• Validation commandes</a:t>
             </a:r>
           </a:p>
         </p:txBody>
@@ -9629,7 +8295,7 @@
                   <a:srgbClr val="2C2C2C"/>
                 </a:solidFill>
               </a:rPr>
-              <a:t>• Validation commandes et suivi livraison</a:t>
+              <a:t>• Chat et prix personnalisés</a:t>
             </a:r>
           </a:p>
         </p:txBody>
@@ -9707,7 +8373,7 @@
                   <a:srgbClr val="2C2C2C"/>
                 </a:solidFill>
               </a:rPr>
-              <a:t>• Modération du chat et fixation des prix</a:t>
+              <a:t>• Portefeuille limité</a:t>
             </a:r>
           </a:p>
         </p:txBody>
@@ -9741,7 +8407,7 @@
                   <a:srgbClr val="666666"/>
                 </a:solidFill>
               </a:rPr>
-              <a:t>Présentation HB Commerce · 6/14</a:t>
+              <a:t>Présentation HB Commerce · 6/12</a:t>
             </a:r>
           </a:p>
         </p:txBody>
@@ -9817,7 +8483,7 @@
       </p:sp>
       <p:pic>
         <p:nvPicPr>
-          <p:cNvPr id="3" name="Picture 2" descr="hb-commerce-logo.png"/>
+          <p:cNvPr id="3" name="Picture 2" descr="hb-commerce-logo-temp.png"/>
           <p:cNvPicPr>
             <a:picLocks noChangeAspect="1"/>
           </p:cNvPicPr>
@@ -9847,8 +8513,8 @@
         </p:nvSpPr>
         <p:spPr>
           <a:xfrm>
-            <a:off x="9464040" y="155448"/>
-            <a:ext cx="2331720" cy="274320"/>
+            <a:off x="9326880" y="155448"/>
+            <a:ext cx="2560320" cy="274320"/>
           </a:xfrm>
           <a:prstGeom prst="rect">
             <a:avLst/>
@@ -9901,7 +8567,7 @@
                   <a:srgbClr val="0F3D32"/>
                 </a:solidFill>
               </a:rPr>
-              <a:t>Dashboard super root</a:t>
+              <a:t>Fournisseurs</a:t>
             </a:r>
           </a:p>
         </p:txBody>
@@ -10022,7 +8688,7 @@
                   <a:srgbClr val="2C2C2C"/>
                 </a:solidFill>
               </a:rPr>
-              <a:t>• Gestion globale des profils et rôles</a:t>
+              <a:t>• Fiche fournisseur</a:t>
             </a:r>
           </a:p>
         </p:txBody>
@@ -10100,7 +8766,7 @@
                   <a:srgbClr val="2C2C2C"/>
                 </a:solidFill>
               </a:rPr>
-              <a:t>• Création et modification utilisateurs</a:t>
+              <a:t>• Compte supplier</a:t>
             </a:r>
           </a:p>
         </p:txBody>
@@ -10178,7 +8844,7 @@
                   <a:srgbClr val="2C2C2C"/>
                 </a:solidFill>
               </a:rPr>
-              <a:t>• Accès au dashboard admin</a:t>
+              <a:t>• Espace supplier.html</a:t>
             </a:r>
           </a:p>
         </p:txBody>
@@ -10256,7 +8922,7 @@
                   <a:srgbClr val="2C2C2C"/>
                 </a:solidFill>
               </a:rPr>
-              <a:t>• Pilotage des prix personnalisés</a:t>
+              <a:t>• Gestion stock disponible/réservé</a:t>
             </a:r>
           </a:p>
         </p:txBody>
@@ -10334,7 +9000,7 @@
                   <a:srgbClr val="2C2C2C"/>
                 </a:solidFill>
               </a:rPr>
-              <a:t>• Supervision des droits et accès</a:t>
+              <a:t>• Commandes approvisionnement</a:t>
             </a:r>
           </a:p>
         </p:txBody>
@@ -10368,7 +9034,7 @@
                   <a:srgbClr val="666666"/>
                 </a:solidFill>
               </a:rPr>
-              <a:t>Présentation HB Commerce · 7/14</a:t>
+              <a:t>Présentation HB Commerce · 7/12</a:t>
             </a:r>
           </a:p>
         </p:txBody>
@@ -10444,7 +9110,7 @@
       </p:sp>
       <p:pic>
         <p:nvPicPr>
-          <p:cNvPr id="3" name="Picture 2" descr="hb-commerce-logo.png"/>
+          <p:cNvPr id="3" name="Picture 2" descr="hb-commerce-logo-temp.png"/>
           <p:cNvPicPr>
             <a:picLocks noChangeAspect="1"/>
           </p:cNvPicPr>
@@ -10474,8 +9140,8 @@
         </p:nvSpPr>
         <p:spPr>
           <a:xfrm>
-            <a:off x="9464040" y="155448"/>
-            <a:ext cx="2331720" cy="274320"/>
+            <a:off x="9326880" y="155448"/>
+            <a:ext cx="2560320" cy="274320"/>
           </a:xfrm>
           <a:prstGeom prst="rect">
             <a:avLst/>
@@ -10528,7 +9194,7 @@
                   <a:srgbClr val="0F3D32"/>
                 </a:solidFill>
               </a:rPr>
-              <a:t>Gestion fournisseurs</a:t>
+              <a:t>Stock et délais</a:t>
             </a:r>
           </a:p>
         </p:txBody>
@@ -10649,7 +9315,7 @@
                   <a:srgbClr val="2C2C2C"/>
                 </a:solidFill>
               </a:rPr>
-              <a:t>• Fiche fournisseur complète</a:t>
+              <a:t>• Stock par produit/fournisseur</a:t>
             </a:r>
           </a:p>
         </p:txBody>
@@ -10727,7 +9393,7 @@
                   <a:srgbClr val="2C2C2C"/>
                 </a:solidFill>
               </a:rPr>
-              <a:t>• Compte fournisseur dédié</a:t>
+              <a:t>• Délai fournisseur</a:t>
             </a:r>
           </a:p>
         </p:txBody>
@@ -10805,7 +9471,7 @@
                   <a:srgbClr val="2C2C2C"/>
                 </a:solidFill>
               </a:rPr>
-              <a:t>• Produits rattachés à un fournisseur</a:t>
+              <a:t>• Délai client estimé</a:t>
             </a:r>
           </a:p>
         </p:txBody>
@@ -10883,66 +9549,21 @@
                   <a:srgbClr val="2C2C2C"/>
                 </a:solidFill>
               </a:rPr>
-              <a:t>• Commandes d’approvisionnement HB Commerce</a:t>
-            </a:r>
-          </a:p>
-        </p:txBody>
-      </p:sp>
-      <p:sp>
-        <p:nvSpPr>
-          <p:cNvPr id="15" name="Rounded Rectangle 14"/>
-          <p:cNvSpPr/>
-          <p:nvPr/>
-        </p:nvSpPr>
-        <p:spPr>
-          <a:xfrm>
-            <a:off x="777240" y="4114800"/>
-            <a:ext cx="10561320" cy="475488"/>
-          </a:xfrm>
-          <a:prstGeom prst="roundRect">
-            <a:avLst/>
-          </a:prstGeom>
-          <a:solidFill>
-            <a:srgbClr val="FFFFFF"/>
-          </a:solidFill>
-          <a:ln>
-            <a:solidFill>
-              <a:srgbClr val="E8E4DC"/>
-            </a:solidFill>
-          </a:ln>
-        </p:spPr>
-        <p:style>
-          <a:lnRef idx="1">
-            <a:schemeClr val="accent1"/>
-          </a:lnRef>
-          <a:fillRef idx="3">
-            <a:schemeClr val="accent1"/>
-          </a:fillRef>
-          <a:effectRef idx="2">
-            <a:schemeClr val="accent1"/>
-          </a:effectRef>
-          <a:fontRef idx="minor">
-            <a:schemeClr val="lt1"/>
-          </a:fontRef>
-        </p:style>
-        <p:txBody>
-          <a:bodyPr rtlCol="0" anchor="ctr"/>
-          <a:lstStyle/>
-          <a:p>
-            <a:pPr algn="ctr"/>
-          </a:p>
-        </p:txBody>
-      </p:sp>
-      <p:sp>
-        <p:nvSpPr>
-          <p:cNvPr id="16" name="TextBox 15"/>
+              <a:t>• Date estimée enregistrée sur commande</a:t>
+            </a:r>
+          </a:p>
+        </p:txBody>
+      </p:sp>
+      <p:sp>
+        <p:nvSpPr>
+          <p:cNvPr id="15" name="TextBox 14"/>
           <p:cNvSpPr txBox="1"/>
           <p:nvPr/>
         </p:nvSpPr>
         <p:spPr>
           <a:xfrm>
-            <a:off x="987552" y="4178808"/>
-            <a:ext cx="10104120" cy="320040"/>
+            <a:off x="594360" y="6446520"/>
+            <a:ext cx="10972800" cy="228600"/>
           </a:xfrm>
           <a:prstGeom prst="rect">
             <a:avLst/>
@@ -10955,47 +9576,14 @@
           </a:bodyPr>
           <a:lstStyle/>
           <a:p>
-            <a:r>
-              <a:rPr sz="1700">
-                <a:solidFill>
-                  <a:srgbClr val="2C2C2C"/>
+            <a:pPr algn="r"/>
+            <a:r>
+              <a:rPr sz="900">
+                <a:solidFill>
+                  <a:srgbClr val="666666"/>
                 </a:solidFill>
               </a:rPr>
-              <a:t>• Mise à jour stock et délais fournisseur</a:t>
-            </a:r>
-          </a:p>
-        </p:txBody>
-      </p:sp>
-      <p:sp>
-        <p:nvSpPr>
-          <p:cNvPr id="17" name="TextBox 16"/>
-          <p:cNvSpPr txBox="1"/>
-          <p:nvPr/>
-        </p:nvSpPr>
-        <p:spPr>
-          <a:xfrm>
-            <a:off x="594360" y="6446520"/>
-            <a:ext cx="10972800" cy="228600"/>
-          </a:xfrm>
-          <a:prstGeom prst="rect">
-            <a:avLst/>
-          </a:prstGeom>
-          <a:noFill/>
-        </p:spPr>
-        <p:txBody>
-          <a:bodyPr wrap="none">
-            <a:spAutoFit/>
-          </a:bodyPr>
-          <a:lstStyle/>
-          <a:p>
-            <a:pPr algn="r"/>
-            <a:r>
-              <a:rPr sz="900">
-                <a:solidFill>
-                  <a:srgbClr val="666666"/>
-                </a:solidFill>
-              </a:rPr>
-              <a:t>Présentation HB Commerce · 8/14</a:t>
+              <a:t>Présentation HB Commerce · 8/12</a:t>
             </a:r>
           </a:p>
         </p:txBody>
@@ -11071,7 +9659,7 @@
       </p:sp>
       <p:pic>
         <p:nvPicPr>
-          <p:cNvPr id="3" name="Picture 2" descr="hb-commerce-logo.png"/>
+          <p:cNvPr id="3" name="Picture 2" descr="hb-commerce-logo-temp.png"/>
           <p:cNvPicPr>
             <a:picLocks noChangeAspect="1"/>
           </p:cNvPicPr>
@@ -11101,8 +9689,8 @@
         </p:nvSpPr>
         <p:spPr>
           <a:xfrm>
-            <a:off x="9464040" y="155448"/>
-            <a:ext cx="2331720" cy="274320"/>
+            <a:off x="9326880" y="155448"/>
+            <a:ext cx="2560320" cy="274320"/>
           </a:xfrm>
           <a:prstGeom prst="rect">
             <a:avLst/>
@@ -11155,7 +9743,7 @@
                   <a:srgbClr val="0F3D32"/>
                 </a:solidFill>
               </a:rPr>
-              <a:t>Stock &amp; délai client</a:t>
+              <a:t>Factures et livraison</a:t>
             </a:r>
           </a:p>
         </p:txBody>
@@ -11276,7 +9864,7 @@
                   <a:srgbClr val="2C2C2C"/>
                 </a:solidFill>
               </a:rPr>
-              <a:t>• Stock disponible par produit/fournisseur</a:t>
+              <a:t>• Facture HTML par commande</a:t>
             </a:r>
           </a:p>
         </p:txBody>
@@ -11354,7 +9942,7 @@
                   <a:srgbClr val="2C2C2C"/>
                 </a:solidFill>
               </a:rPr>
-              <a:t>• Stock réservé pris en compte</a:t>
+              <a:t>• Transporteur et tracking</a:t>
             </a:r>
           </a:p>
         </p:txBody>
@@ -11432,7 +10020,7 @@
                   <a:srgbClr val="2C2C2C"/>
                 </a:solidFill>
               </a:rPr>
-              <a:t>• Délai fournisseur configurable</a:t>
+              <a:t>• Date estimée</a:t>
             </a:r>
           </a:p>
         </p:txBody>
@@ -11510,7 +10098,7 @@
                   <a:srgbClr val="2C2C2C"/>
                 </a:solidFill>
               </a:rPr>
-              <a:t>• Délai client estimé selon disponibilité</a:t>
+              <a:t>• Date livrée</a:t>
             </a:r>
           </a:p>
         </p:txBody>
@@ -11588,7 +10176,7 @@
                   <a:srgbClr val="2C2C2C"/>
                 </a:solidFill>
               </a:rPr>
-              <a:t>• Date estimée enregistrée sur la commande</a:t>
+              <a:t>• Notes livraison</a:t>
             </a:r>
           </a:p>
         </p:txBody>
@@ -11622,7 +10210,7 @@
                   <a:srgbClr val="666666"/>
                 </a:solidFill>
               </a:rPr>
-              <a:t>Présentation HB Commerce · 9/14</a:t>
+              <a:t>Présentation HB Commerce · 9/12</a:t>
             </a:r>
           </a:p>
         </p:txBody>

</xml_diff>